<commit_message>
Profile Update- Vendor Profile Update
</commit_message>
<xml_diff>
--- a/.lessons/53 Profile Update/5 Profile Update- Vendor Profile Update/1.pptx
+++ b/.lessons/53 Profile Update/5 Profile Update- Vendor Profile Update/1.pptx
@@ -8,6 +8,16 @@
     <p:sldId id="413" r:id="rId2"/>
     <p:sldId id="414" r:id="rId3"/>
     <p:sldId id="400" r:id="rId4"/>
+    <p:sldId id="415" r:id="rId5"/>
+    <p:sldId id="416" r:id="rId6"/>
+    <p:sldId id="417" r:id="rId7"/>
+    <p:sldId id="418" r:id="rId8"/>
+    <p:sldId id="419" r:id="rId9"/>
+    <p:sldId id="421" r:id="rId10"/>
+    <p:sldId id="422" r:id="rId11"/>
+    <p:sldId id="423" r:id="rId12"/>
+    <p:sldId id="424" r:id="rId13"/>
+    <p:sldId id="420" r:id="rId14"/>
   </p:sldIdLst>
   <p:sldSz cx="12192000" cy="6858000"/>
   <p:notesSz cx="6858000" cy="9144000"/>
@@ -261,7 +271,7 @@
           <a:p>
             <a:fld id="{3E102D2E-813C-461C-9963-687A650C48C0}" type="datetimeFigureOut">
               <a:rPr lang="en-US" smtClean="0"/>
-              <a:t>6/26/2025</a:t>
+              <a:t>8/4/2025</a:t>
             </a:fld>
             <a:endParaRPr lang="en-US"/>
           </a:p>
@@ -459,7 +469,7 @@
           <a:p>
             <a:fld id="{3E102D2E-813C-461C-9963-687A650C48C0}" type="datetimeFigureOut">
               <a:rPr lang="en-US" smtClean="0"/>
-              <a:t>6/26/2025</a:t>
+              <a:t>8/4/2025</a:t>
             </a:fld>
             <a:endParaRPr lang="en-US"/>
           </a:p>
@@ -667,7 +677,7 @@
           <a:p>
             <a:fld id="{3E102D2E-813C-461C-9963-687A650C48C0}" type="datetimeFigureOut">
               <a:rPr lang="en-US" smtClean="0"/>
-              <a:t>6/26/2025</a:t>
+              <a:t>8/4/2025</a:t>
             </a:fld>
             <a:endParaRPr lang="en-US"/>
           </a:p>
@@ -865,7 +875,7 @@
           <a:p>
             <a:fld id="{3E102D2E-813C-461C-9963-687A650C48C0}" type="datetimeFigureOut">
               <a:rPr lang="en-US" smtClean="0"/>
-              <a:t>6/26/2025</a:t>
+              <a:t>8/4/2025</a:t>
             </a:fld>
             <a:endParaRPr lang="en-US"/>
           </a:p>
@@ -1140,7 +1150,7 @@
           <a:p>
             <a:fld id="{3E102D2E-813C-461C-9963-687A650C48C0}" type="datetimeFigureOut">
               <a:rPr lang="en-US" smtClean="0"/>
-              <a:t>6/26/2025</a:t>
+              <a:t>8/4/2025</a:t>
             </a:fld>
             <a:endParaRPr lang="en-US"/>
           </a:p>
@@ -1405,7 +1415,7 @@
           <a:p>
             <a:fld id="{3E102D2E-813C-461C-9963-687A650C48C0}" type="datetimeFigureOut">
               <a:rPr lang="en-US" smtClean="0"/>
-              <a:t>6/26/2025</a:t>
+              <a:t>8/4/2025</a:t>
             </a:fld>
             <a:endParaRPr lang="en-US"/>
           </a:p>
@@ -1817,7 +1827,7 @@
           <a:p>
             <a:fld id="{3E102D2E-813C-461C-9963-687A650C48C0}" type="datetimeFigureOut">
               <a:rPr lang="en-US" smtClean="0"/>
-              <a:t>6/26/2025</a:t>
+              <a:t>8/4/2025</a:t>
             </a:fld>
             <a:endParaRPr lang="en-US"/>
           </a:p>
@@ -1958,7 +1968,7 @@
           <a:p>
             <a:fld id="{3E102D2E-813C-461C-9963-687A650C48C0}" type="datetimeFigureOut">
               <a:rPr lang="en-US" smtClean="0"/>
-              <a:t>6/26/2025</a:t>
+              <a:t>8/4/2025</a:t>
             </a:fld>
             <a:endParaRPr lang="en-US"/>
           </a:p>
@@ -2071,7 +2081,7 @@
           <a:p>
             <a:fld id="{3E102D2E-813C-461C-9963-687A650C48C0}" type="datetimeFigureOut">
               <a:rPr lang="en-US" smtClean="0"/>
-              <a:t>6/26/2025</a:t>
+              <a:t>8/4/2025</a:t>
             </a:fld>
             <a:endParaRPr lang="en-US"/>
           </a:p>
@@ -2382,7 +2392,7 @@
           <a:p>
             <a:fld id="{3E102D2E-813C-461C-9963-687A650C48C0}" type="datetimeFigureOut">
               <a:rPr lang="en-US" smtClean="0"/>
-              <a:t>6/26/2025</a:t>
+              <a:t>8/4/2025</a:t>
             </a:fld>
             <a:endParaRPr lang="en-US"/>
           </a:p>
@@ -2670,7 +2680,7 @@
           <a:p>
             <a:fld id="{3E102D2E-813C-461C-9963-687A650C48C0}" type="datetimeFigureOut">
               <a:rPr lang="en-US" smtClean="0"/>
-              <a:t>6/26/2025</a:t>
+              <a:t>8/4/2025</a:t>
             </a:fld>
             <a:endParaRPr lang="en-US"/>
           </a:p>
@@ -2911,7 +2921,7 @@
           <a:p>
             <a:fld id="{3E102D2E-813C-461C-9963-687A650C48C0}" type="datetimeFigureOut">
               <a:rPr lang="en-US" smtClean="0"/>
-              <a:t>6/26/2025</a:t>
+              <a:t>8/4/2025</a:t>
             </a:fld>
             <a:endParaRPr lang="en-US"/>
           </a:p>
@@ -3369,6 +3379,151 @@
               <a:buNone/>
             </a:pPr>
             <a:r>
+              <a:rPr lang="az-Latn-AZ" altLang="en-US" sz="1300">
+                <a:latin typeface="Arial" panose="020B0604020202020204" pitchFamily="34" charset="0"/>
+              </a:rPr>
+              <a:t>Bu dərs </a:t>
+            </a:r>
+            <a:r>
+              <a:rPr lang="az-Latn-AZ" altLang="en-US" sz="1300" b="1">
+                <a:latin typeface="Arial" panose="020B0604020202020204" pitchFamily="34" charset="0"/>
+              </a:rPr>
+              <a:t>VENDOR</a:t>
+            </a:r>
+            <a:r>
+              <a:rPr lang="az-Latn-AZ" altLang="en-US" sz="1300">
+                <a:latin typeface="Arial" panose="020B0604020202020204" pitchFamily="34" charset="0"/>
+              </a:rPr>
+              <a:t> kimi sistemə giriş edirik.</a:t>
+            </a:r>
+            <a:endParaRPr kumimoji="0" lang="en-US" altLang="en-US" sz="1300" b="0" i="0" u="none" strike="noStrike" cap="none" normalizeH="0" baseline="0">
+              <a:ln>
+                <a:noFill/>
+              </a:ln>
+              <a:solidFill>
+                <a:schemeClr val="tx1"/>
+              </a:solidFill>
+              <a:effectLst/>
+              <a:latin typeface="Arial" panose="020B0604020202020204" pitchFamily="34" charset="0"/>
+            </a:endParaRPr>
+          </a:p>
+        </p:txBody>
+      </p:sp>
+      <p:pic>
+        <p:nvPicPr>
+          <p:cNvPr id="4" name="Picture 3">
+            <a:extLst>
+              <a:ext uri="{FF2B5EF4-FFF2-40B4-BE49-F238E27FC236}">
+                <a16:creationId xmlns:a16="http://schemas.microsoft.com/office/drawing/2014/main" id="{F192401A-2EBB-0060-51FA-545F2EECB310}"/>
+              </a:ext>
+            </a:extLst>
+          </p:cNvPr>
+          <p:cNvPicPr>
+            <a:picLocks noChangeAspect="1"/>
+          </p:cNvPicPr>
+          <p:nvPr/>
+        </p:nvPicPr>
+        <p:blipFill>
+          <a:blip r:embed="rId2"/>
+          <a:stretch>
+            <a:fillRect/>
+          </a:stretch>
+        </p:blipFill>
+        <p:spPr>
+          <a:xfrm>
+            <a:off x="3282536" y="2126896"/>
+            <a:ext cx="5477639" cy="4134427"/>
+          </a:xfrm>
+          <a:prstGeom prst="rect">
+            <a:avLst/>
+          </a:prstGeom>
+          <a:ln w="38100" cap="sq">
+            <a:solidFill>
+              <a:srgbClr val="000000"/>
+            </a:solidFill>
+            <a:prstDash val="solid"/>
+            <a:miter lim="800000"/>
+          </a:ln>
+          <a:effectLst>
+            <a:outerShdw blurRad="50800" dist="38100" dir="2700000" algn="tl" rotWithShape="0">
+              <a:srgbClr val="000000">
+                <a:alpha val="43000"/>
+              </a:srgbClr>
+            </a:outerShdw>
+          </a:effectLst>
+        </p:spPr>
+      </p:pic>
+    </p:spTree>
+    <p:extLst>
+      <p:ext uri="{BB962C8B-B14F-4D97-AF65-F5344CB8AC3E}">
+        <p14:creationId xmlns:p14="http://schemas.microsoft.com/office/powerpoint/2010/main" val="3863838039"/>
+      </p:ext>
+    </p:extLst>
+  </p:cSld>
+  <p:clrMapOvr>
+    <a:masterClrMapping/>
+  </p:clrMapOvr>
+</p:sld>
+</file>
+
+<file path=ppt/slides/slide10.xml><?xml version="1.0" encoding="utf-8"?>
+<p:sld xmlns:a="http://schemas.openxmlformats.org/drawingml/2006/main" xmlns:r="http://schemas.openxmlformats.org/officeDocument/2006/relationships" xmlns:p="http://schemas.openxmlformats.org/presentationml/2006/main">
+  <p:cSld>
+    <p:spTree>
+      <p:nvGrpSpPr>
+        <p:cNvPr id="1" name="">
+          <a:extLst>
+            <a:ext uri="{FF2B5EF4-FFF2-40B4-BE49-F238E27FC236}">
+              <a16:creationId xmlns:a16="http://schemas.microsoft.com/office/drawing/2014/main" id="{CEEE2CCC-EE18-9125-F09E-689247D92D76}"/>
+            </a:ext>
+          </a:extLst>
+        </p:cNvPr>
+        <p:cNvGrpSpPr/>
+        <p:nvPr/>
+      </p:nvGrpSpPr>
+      <p:grpSpPr>
+        <a:xfrm>
+          <a:off x="0" y="0"/>
+          <a:ext cx="0" cy="0"/>
+          <a:chOff x="0" y="0"/>
+          <a:chExt cx="0" cy="0"/>
+        </a:xfrm>
+      </p:grpSpPr>
+      <p:sp>
+        <p:nvSpPr>
+          <p:cNvPr id="3" name="TextBox 2">
+            <a:extLst>
+              <a:ext uri="{FF2B5EF4-FFF2-40B4-BE49-F238E27FC236}">
+                <a16:creationId xmlns:a16="http://schemas.microsoft.com/office/drawing/2014/main" id="{707F5503-F91F-1ECD-21E0-8D7656BE9596}"/>
+              </a:ext>
+            </a:extLst>
+          </p:cNvPr>
+          <p:cNvSpPr txBox="1"/>
+          <p:nvPr/>
+        </p:nvSpPr>
+        <p:spPr>
+          <a:xfrm>
+            <a:off x="217714" y="255046"/>
+            <a:ext cx="11756571" cy="355354"/>
+          </a:xfrm>
+          <a:prstGeom prst="rect">
+            <a:avLst/>
+          </a:prstGeom>
+          <a:noFill/>
+        </p:spPr>
+        <p:txBody>
+          <a:bodyPr wrap="square">
+            <a:spAutoFit/>
+          </a:bodyPr>
+          <a:lstStyle/>
+          <a:p>
+            <a:pPr>
+              <a:lnSpc>
+                <a:spcPct val="150000"/>
+              </a:lnSpc>
+              <a:buNone/>
+            </a:pPr>
+            <a:r>
               <a:rPr kumimoji="0" lang="en-US" altLang="en-US" sz="1300" b="0" i="0" u="none" strike="noStrike" cap="none" normalizeH="0" baseline="0">
                 <a:ln>
                   <a:noFill/>
@@ -3387,7 +3542,265 @@
     </p:spTree>
     <p:extLst>
       <p:ext uri="{BB962C8B-B14F-4D97-AF65-F5344CB8AC3E}">
-        <p14:creationId xmlns:p14="http://schemas.microsoft.com/office/powerpoint/2010/main" val="3863838039"/>
+        <p14:creationId xmlns:p14="http://schemas.microsoft.com/office/powerpoint/2010/main" val="1200128115"/>
+      </p:ext>
+    </p:extLst>
+  </p:cSld>
+  <p:clrMapOvr>
+    <a:masterClrMapping/>
+  </p:clrMapOvr>
+</p:sld>
+</file>
+
+<file path=ppt/slides/slide11.xml><?xml version="1.0" encoding="utf-8"?>
+<p:sld xmlns:a="http://schemas.openxmlformats.org/drawingml/2006/main" xmlns:r="http://schemas.openxmlformats.org/officeDocument/2006/relationships" xmlns:p="http://schemas.openxmlformats.org/presentationml/2006/main">
+  <p:cSld>
+    <p:spTree>
+      <p:nvGrpSpPr>
+        <p:cNvPr id="1" name="">
+          <a:extLst>
+            <a:ext uri="{FF2B5EF4-FFF2-40B4-BE49-F238E27FC236}">
+              <a16:creationId xmlns:a16="http://schemas.microsoft.com/office/drawing/2014/main" id="{9412B487-AAB7-8161-EEDC-2B1CD2610D0A}"/>
+            </a:ext>
+          </a:extLst>
+        </p:cNvPr>
+        <p:cNvGrpSpPr/>
+        <p:nvPr/>
+      </p:nvGrpSpPr>
+      <p:grpSpPr>
+        <a:xfrm>
+          <a:off x="0" y="0"/>
+          <a:ext cx="0" cy="0"/>
+          <a:chOff x="0" y="0"/>
+          <a:chExt cx="0" cy="0"/>
+        </a:xfrm>
+      </p:grpSpPr>
+      <p:sp>
+        <p:nvSpPr>
+          <p:cNvPr id="3" name="TextBox 2">
+            <a:extLst>
+              <a:ext uri="{FF2B5EF4-FFF2-40B4-BE49-F238E27FC236}">
+                <a16:creationId xmlns:a16="http://schemas.microsoft.com/office/drawing/2014/main" id="{E804FCC4-840B-DCD2-0A6A-0B9A490CF303}"/>
+              </a:ext>
+            </a:extLst>
+          </p:cNvPr>
+          <p:cNvSpPr txBox="1"/>
+          <p:nvPr/>
+        </p:nvSpPr>
+        <p:spPr>
+          <a:xfrm>
+            <a:off x="217714" y="255046"/>
+            <a:ext cx="11756571" cy="355354"/>
+          </a:xfrm>
+          <a:prstGeom prst="rect">
+            <a:avLst/>
+          </a:prstGeom>
+          <a:noFill/>
+        </p:spPr>
+        <p:txBody>
+          <a:bodyPr wrap="square">
+            <a:spAutoFit/>
+          </a:bodyPr>
+          <a:lstStyle/>
+          <a:p>
+            <a:pPr>
+              <a:lnSpc>
+                <a:spcPct val="150000"/>
+              </a:lnSpc>
+              <a:buNone/>
+            </a:pPr>
+            <a:r>
+              <a:rPr kumimoji="0" lang="en-US" altLang="en-US" sz="1300" b="0" i="0" u="none" strike="noStrike" cap="none" normalizeH="0" baseline="0">
+                <a:ln>
+                  <a:noFill/>
+                </a:ln>
+                <a:solidFill>
+                  <a:schemeClr val="tx1"/>
+                </a:solidFill>
+                <a:effectLst/>
+                <a:latin typeface="Arial" panose="020B0604020202020204" pitchFamily="34" charset="0"/>
+              </a:rPr>
+              <a:t>.</a:t>
+            </a:r>
+          </a:p>
+        </p:txBody>
+      </p:sp>
+    </p:spTree>
+    <p:extLst>
+      <p:ext uri="{BB962C8B-B14F-4D97-AF65-F5344CB8AC3E}">
+        <p14:creationId xmlns:p14="http://schemas.microsoft.com/office/powerpoint/2010/main" val="2770946909"/>
+      </p:ext>
+    </p:extLst>
+  </p:cSld>
+  <p:clrMapOvr>
+    <a:masterClrMapping/>
+  </p:clrMapOvr>
+</p:sld>
+</file>
+
+<file path=ppt/slides/slide12.xml><?xml version="1.0" encoding="utf-8"?>
+<p:sld xmlns:a="http://schemas.openxmlformats.org/drawingml/2006/main" xmlns:r="http://schemas.openxmlformats.org/officeDocument/2006/relationships" xmlns:p="http://schemas.openxmlformats.org/presentationml/2006/main">
+  <p:cSld>
+    <p:spTree>
+      <p:nvGrpSpPr>
+        <p:cNvPr id="1" name="">
+          <a:extLst>
+            <a:ext uri="{FF2B5EF4-FFF2-40B4-BE49-F238E27FC236}">
+              <a16:creationId xmlns:a16="http://schemas.microsoft.com/office/drawing/2014/main" id="{75C0565A-49A4-1217-1868-8F43E77FE74C}"/>
+            </a:ext>
+          </a:extLst>
+        </p:cNvPr>
+        <p:cNvGrpSpPr/>
+        <p:nvPr/>
+      </p:nvGrpSpPr>
+      <p:grpSpPr>
+        <a:xfrm>
+          <a:off x="0" y="0"/>
+          <a:ext cx="0" cy="0"/>
+          <a:chOff x="0" y="0"/>
+          <a:chExt cx="0" cy="0"/>
+        </a:xfrm>
+      </p:grpSpPr>
+      <p:sp>
+        <p:nvSpPr>
+          <p:cNvPr id="3" name="TextBox 2">
+            <a:extLst>
+              <a:ext uri="{FF2B5EF4-FFF2-40B4-BE49-F238E27FC236}">
+                <a16:creationId xmlns:a16="http://schemas.microsoft.com/office/drawing/2014/main" id="{764F186D-79BF-64A1-5F2A-F723F07A86BA}"/>
+              </a:ext>
+            </a:extLst>
+          </p:cNvPr>
+          <p:cNvSpPr txBox="1"/>
+          <p:nvPr/>
+        </p:nvSpPr>
+        <p:spPr>
+          <a:xfrm>
+            <a:off x="217714" y="255046"/>
+            <a:ext cx="11756571" cy="355354"/>
+          </a:xfrm>
+          <a:prstGeom prst="rect">
+            <a:avLst/>
+          </a:prstGeom>
+          <a:noFill/>
+        </p:spPr>
+        <p:txBody>
+          <a:bodyPr wrap="square">
+            <a:spAutoFit/>
+          </a:bodyPr>
+          <a:lstStyle/>
+          <a:p>
+            <a:pPr>
+              <a:lnSpc>
+                <a:spcPct val="150000"/>
+              </a:lnSpc>
+              <a:buNone/>
+            </a:pPr>
+            <a:r>
+              <a:rPr kumimoji="0" lang="en-US" altLang="en-US" sz="1300" b="0" i="0" u="none" strike="noStrike" cap="none" normalizeH="0" baseline="0">
+                <a:ln>
+                  <a:noFill/>
+                </a:ln>
+                <a:solidFill>
+                  <a:schemeClr val="tx1"/>
+                </a:solidFill>
+                <a:effectLst/>
+                <a:latin typeface="Arial" panose="020B0604020202020204" pitchFamily="34" charset="0"/>
+              </a:rPr>
+              <a:t>.</a:t>
+            </a:r>
+          </a:p>
+        </p:txBody>
+      </p:sp>
+    </p:spTree>
+    <p:extLst>
+      <p:ext uri="{BB962C8B-B14F-4D97-AF65-F5344CB8AC3E}">
+        <p14:creationId xmlns:p14="http://schemas.microsoft.com/office/powerpoint/2010/main" val="3896819617"/>
+      </p:ext>
+    </p:extLst>
+  </p:cSld>
+  <p:clrMapOvr>
+    <a:masterClrMapping/>
+  </p:clrMapOvr>
+</p:sld>
+</file>
+
+<file path=ppt/slides/slide13.xml><?xml version="1.0" encoding="utf-8"?>
+<p:sld xmlns:a="http://schemas.openxmlformats.org/drawingml/2006/main" xmlns:r="http://schemas.openxmlformats.org/officeDocument/2006/relationships" xmlns:p="http://schemas.openxmlformats.org/presentationml/2006/main">
+  <p:cSld>
+    <p:spTree>
+      <p:nvGrpSpPr>
+        <p:cNvPr id="1" name="">
+          <a:extLst>
+            <a:ext uri="{FF2B5EF4-FFF2-40B4-BE49-F238E27FC236}">
+              <a16:creationId xmlns:a16="http://schemas.microsoft.com/office/drawing/2014/main" id="{4285D766-EB02-D98E-8226-2176CBA43E0E}"/>
+            </a:ext>
+          </a:extLst>
+        </p:cNvPr>
+        <p:cNvGrpSpPr/>
+        <p:nvPr/>
+      </p:nvGrpSpPr>
+      <p:grpSpPr>
+        <a:xfrm>
+          <a:off x="0" y="0"/>
+          <a:ext cx="0" cy="0"/>
+          <a:chOff x="0" y="0"/>
+          <a:chExt cx="0" cy="0"/>
+        </a:xfrm>
+      </p:grpSpPr>
+      <p:sp>
+        <p:nvSpPr>
+          <p:cNvPr id="3" name="TextBox 2">
+            <a:extLst>
+              <a:ext uri="{FF2B5EF4-FFF2-40B4-BE49-F238E27FC236}">
+                <a16:creationId xmlns:a16="http://schemas.microsoft.com/office/drawing/2014/main" id="{9563A46C-50A6-30E9-F72D-9553E191B3E1}"/>
+              </a:ext>
+            </a:extLst>
+          </p:cNvPr>
+          <p:cNvSpPr txBox="1"/>
+          <p:nvPr/>
+        </p:nvSpPr>
+        <p:spPr>
+          <a:xfrm>
+            <a:off x="217714" y="255046"/>
+            <a:ext cx="11756571" cy="355354"/>
+          </a:xfrm>
+          <a:prstGeom prst="rect">
+            <a:avLst/>
+          </a:prstGeom>
+          <a:noFill/>
+        </p:spPr>
+        <p:txBody>
+          <a:bodyPr wrap="square">
+            <a:spAutoFit/>
+          </a:bodyPr>
+          <a:lstStyle/>
+          <a:p>
+            <a:pPr>
+              <a:lnSpc>
+                <a:spcPct val="150000"/>
+              </a:lnSpc>
+              <a:buNone/>
+            </a:pPr>
+            <a:r>
+              <a:rPr kumimoji="0" lang="en-US" altLang="en-US" sz="1300" b="0" i="0" u="none" strike="noStrike" cap="none" normalizeH="0" baseline="0">
+                <a:ln>
+                  <a:noFill/>
+                </a:ln>
+                <a:solidFill>
+                  <a:schemeClr val="tx1"/>
+                </a:solidFill>
+                <a:effectLst/>
+                <a:latin typeface="Arial" panose="020B0604020202020204" pitchFamily="34" charset="0"/>
+              </a:rPr>
+              <a:t>.</a:t>
+            </a:r>
+          </a:p>
+        </p:txBody>
+      </p:sp>
+    </p:spTree>
+    <p:extLst>
+      <p:ext uri="{BB962C8B-B14F-4D97-AF65-F5344CB8AC3E}">
+        <p14:creationId xmlns:p14="http://schemas.microsoft.com/office/powerpoint/2010/main" val="2021635448"/>
       </p:ext>
     </p:extLst>
   </p:cSld>
@@ -3435,7 +3848,7 @@
         <p:spPr>
           <a:xfrm>
             <a:off x="217714" y="255046"/>
-            <a:ext cx="11756571" cy="355354"/>
+            <a:ext cx="5725886" cy="1555682"/>
           </a:xfrm>
           <a:prstGeom prst="rect">
             <a:avLst/>
@@ -3455,7 +3868,87 @@
               <a:buNone/>
             </a:pPr>
             <a:r>
-              <a:rPr kumimoji="0" lang="en-US" altLang="en-US" sz="1300" b="0" i="0" u="none" strike="noStrike" cap="none" normalizeH="0" baseline="0">
+              <a:rPr lang="az-Latn-AZ" altLang="en-US" sz="1300">
+                <a:latin typeface="Arial" panose="020B0604020202020204" pitchFamily="34" charset="0"/>
+              </a:rPr>
+              <a:t>`</a:t>
+            </a:r>
+            <a:r>
+              <a:rPr lang="en-US" altLang="en-US" sz="1300" b="1">
+                <a:latin typeface="Arial" panose="020B0604020202020204" pitchFamily="34" charset="0"/>
+              </a:rPr>
+              <a:t>resources\views\vendor\dashboard\dashboard.blade.php</a:t>
+            </a:r>
+            <a:r>
+              <a:rPr lang="az-Latn-AZ" altLang="en-US" sz="1300">
+                <a:latin typeface="Arial" panose="020B0604020202020204" pitchFamily="34" charset="0"/>
+              </a:rPr>
+              <a:t>`  faylında </a:t>
+            </a:r>
+            <a:r>
+              <a:rPr lang="en-US" altLang="en-US" sz="1300" b="1">
+                <a:latin typeface="Arial" panose="020B0604020202020204" pitchFamily="34" charset="0"/>
+              </a:rPr>
+              <a:t>@extends </a:t>
+            </a:r>
+            <a:r>
+              <a:rPr lang="az-Latn-AZ" altLang="en-US" sz="1300">
+                <a:latin typeface="Arial" panose="020B0604020202020204" pitchFamily="34" charset="0"/>
+              </a:rPr>
+              <a:t>və </a:t>
+            </a:r>
+            <a:r>
+              <a:rPr lang="en-US" altLang="en-US" sz="1300" b="1">
+                <a:latin typeface="Arial" panose="020B0604020202020204" pitchFamily="34" charset="0"/>
+              </a:rPr>
+              <a:t>@include </a:t>
+            </a:r>
+            <a:r>
+              <a:rPr lang="az-Latn-AZ" altLang="en-US" sz="1300">
+                <a:latin typeface="Arial" panose="020B0604020202020204" pitchFamily="34" charset="0"/>
+              </a:rPr>
+              <a:t>direktivlərində `</a:t>
+            </a:r>
+            <a:r>
+              <a:rPr lang="az-Latn-AZ" altLang="en-US" sz="1300" b="1">
+                <a:latin typeface="Arial" panose="020B0604020202020204" pitchFamily="34" charset="0"/>
+              </a:rPr>
+              <a:t>frontend</a:t>
+            </a:r>
+            <a:r>
+              <a:rPr lang="az-Latn-AZ" altLang="en-US" sz="1300">
+                <a:latin typeface="Arial" panose="020B0604020202020204" pitchFamily="34" charset="0"/>
+              </a:rPr>
+              <a:t>` yazılmışdı. </a:t>
+            </a:r>
+          </a:p>
+          <a:p>
+            <a:pPr>
+              <a:lnSpc>
+                <a:spcPct val="150000"/>
+              </a:lnSpc>
+              <a:buNone/>
+            </a:pPr>
+            <a:endParaRPr kumimoji="0" lang="az-Latn-AZ" altLang="en-US" sz="1300" b="0" i="0" u="none" strike="noStrike" cap="none" normalizeH="0" baseline="0">
+              <a:ln>
+                <a:noFill/>
+              </a:ln>
+              <a:solidFill>
+                <a:schemeClr val="tx1"/>
+              </a:solidFill>
+              <a:effectLst/>
+              <a:latin typeface="Arial" panose="020B0604020202020204" pitchFamily="34" charset="0"/>
+            </a:endParaRPr>
+          </a:p>
+          <a:p>
+            <a:pPr>
+              <a:lnSpc>
+                <a:spcPct val="150000"/>
+              </a:lnSpc>
+              <a:buNone/>
+            </a:pPr>
+            <a:r>
+              <a:rPr kumimoji="0" lang="az-Latn-AZ" altLang="en-US" sz="1300" b="0" i="0" u="none" strike="noStrike" cap="none" normalizeH="0" baseline="0">
                 <a:ln>
                   <a:noFill/>
                 </a:ln>
@@ -3465,11 +3958,93 @@
                 <a:effectLst/>
                 <a:latin typeface="Arial" panose="020B0604020202020204" pitchFamily="34" charset="0"/>
               </a:rPr>
-              <a:t>.</a:t>
-            </a:r>
-          </a:p>
-        </p:txBody>
-      </p:sp>
+              <a:t>Bu</a:t>
+            </a:r>
+            <a:r>
+              <a:rPr lang="az-Latn-AZ" altLang="en-US" sz="1300">
+                <a:latin typeface="Arial" panose="020B0604020202020204" pitchFamily="34" charset="0"/>
+              </a:rPr>
+              <a:t>nu düzəldərək `</a:t>
+            </a:r>
+            <a:r>
+              <a:rPr lang="az-Latn-AZ" altLang="en-US" sz="1300" b="1">
+                <a:latin typeface="Arial" panose="020B0604020202020204" pitchFamily="34" charset="0"/>
+              </a:rPr>
+              <a:t>vendor</a:t>
+            </a:r>
+            <a:r>
+              <a:rPr lang="az-Latn-AZ" altLang="en-US" sz="1300">
+                <a:latin typeface="Arial" panose="020B0604020202020204" pitchFamily="34" charset="0"/>
+              </a:rPr>
+              <a:t>` ilə əvəz edirik. Çünki </a:t>
+            </a:r>
+            <a:r>
+              <a:rPr lang="az-Latn-AZ" altLang="en-US" sz="1300" b="1">
+                <a:latin typeface="Arial" panose="020B0604020202020204" pitchFamily="34" charset="0"/>
+              </a:rPr>
+              <a:t>vendor</a:t>
+            </a:r>
+            <a:r>
+              <a:rPr lang="az-Latn-AZ" altLang="en-US" sz="1300">
+                <a:latin typeface="Arial" panose="020B0604020202020204" pitchFamily="34" charset="0"/>
+              </a:rPr>
+              <a:t> və </a:t>
+            </a:r>
+            <a:r>
+              <a:rPr lang="az-Latn-AZ" altLang="en-US" sz="1300" b="1">
+                <a:latin typeface="Arial" panose="020B0604020202020204" pitchFamily="34" charset="0"/>
+              </a:rPr>
+              <a:t>frontend</a:t>
+            </a:r>
+            <a:r>
+              <a:rPr lang="az-Latn-AZ" altLang="en-US" sz="1300">
+                <a:latin typeface="Arial" panose="020B0604020202020204" pitchFamily="34" charset="0"/>
+              </a:rPr>
+              <a:t> üçün istifadə edilən səhifələr fərqlidir.</a:t>
+            </a:r>
+            <a:endParaRPr kumimoji="0" lang="en-US" altLang="en-US" sz="1300" b="0" i="0" u="none" strike="noStrike" cap="none" normalizeH="0" baseline="0">
+              <a:ln>
+                <a:noFill/>
+              </a:ln>
+              <a:solidFill>
+                <a:schemeClr val="tx1"/>
+              </a:solidFill>
+              <a:effectLst/>
+              <a:latin typeface="Arial" panose="020B0604020202020204" pitchFamily="34" charset="0"/>
+            </a:endParaRPr>
+          </a:p>
+        </p:txBody>
+      </p:sp>
+      <p:pic>
+        <p:nvPicPr>
+          <p:cNvPr id="4" name="Picture 3">
+            <a:extLst>
+              <a:ext uri="{FF2B5EF4-FFF2-40B4-BE49-F238E27FC236}">
+                <a16:creationId xmlns:a16="http://schemas.microsoft.com/office/drawing/2014/main" id="{5A18537E-B0B7-A43E-DD7E-C4DF579FD2ED}"/>
+              </a:ext>
+            </a:extLst>
+          </p:cNvPr>
+          <p:cNvPicPr>
+            <a:picLocks noChangeAspect="1"/>
+          </p:cNvPicPr>
+          <p:nvPr/>
+        </p:nvPicPr>
+        <p:blipFill>
+          <a:blip r:embed="rId2"/>
+          <a:stretch>
+            <a:fillRect/>
+          </a:stretch>
+        </p:blipFill>
+        <p:spPr>
+          <a:xfrm>
+            <a:off x="6132583" y="0"/>
+            <a:ext cx="6059417" cy="6858000"/>
+          </a:xfrm>
+          <a:prstGeom prst="rect">
+            <a:avLst/>
+          </a:prstGeom>
+        </p:spPr>
+      </p:pic>
     </p:spTree>
     <p:extLst>
       <p:ext uri="{BB962C8B-B14F-4D97-AF65-F5344CB8AC3E}">
@@ -3521,6 +4096,241 @@
         <p:spPr>
           <a:xfrm>
             <a:off x="217714" y="255046"/>
+            <a:ext cx="6313715" cy="1555682"/>
+          </a:xfrm>
+          <a:prstGeom prst="rect">
+            <a:avLst/>
+          </a:prstGeom>
+          <a:noFill/>
+        </p:spPr>
+        <p:txBody>
+          <a:bodyPr wrap="square">
+            <a:spAutoFit/>
+          </a:bodyPr>
+          <a:lstStyle/>
+          <a:p>
+            <a:pPr>
+              <a:lnSpc>
+                <a:spcPct val="150000"/>
+              </a:lnSpc>
+              <a:buNone/>
+            </a:pPr>
+            <a:r>
+              <a:rPr lang="az-Latn-AZ" altLang="en-US" sz="1300" b="1">
+                <a:latin typeface="Arial" panose="020B0604020202020204" pitchFamily="34" charset="0"/>
+              </a:rPr>
+              <a:t>Frontend</a:t>
+            </a:r>
+            <a:r>
+              <a:rPr lang="az-Latn-AZ" altLang="en-US" sz="1300">
+                <a:latin typeface="Arial" panose="020B0604020202020204" pitchFamily="34" charset="0"/>
+              </a:rPr>
+              <a:t> üçün istifadə edilən `</a:t>
+            </a:r>
+            <a:r>
+              <a:rPr lang="az-Latn-AZ" altLang="en-US" sz="1300" b="1">
+                <a:latin typeface="Arial" panose="020B0604020202020204" pitchFamily="34" charset="0"/>
+              </a:rPr>
+              <a:t>profile.blade.php</a:t>
+            </a:r>
+            <a:r>
+              <a:rPr lang="az-Latn-AZ" altLang="en-US" sz="1300">
+                <a:latin typeface="Arial" panose="020B0604020202020204" pitchFamily="34" charset="0"/>
+              </a:rPr>
+              <a:t>` səhifəsini, </a:t>
+            </a:r>
+            <a:r>
+              <a:rPr lang="az-Latn-AZ" altLang="en-US" sz="1300" b="1">
+                <a:latin typeface="Arial" panose="020B0604020202020204" pitchFamily="34" charset="0"/>
+              </a:rPr>
+              <a:t>vendor</a:t>
+            </a:r>
+            <a:r>
+              <a:rPr lang="en-US" altLang="en-US" sz="1300" b="1">
+                <a:latin typeface="Arial" panose="020B0604020202020204" pitchFamily="34" charset="0"/>
+              </a:rPr>
+              <a:t>/dashboard </a:t>
+            </a:r>
+            <a:r>
+              <a:rPr lang="az-Latn-AZ" altLang="en-US" sz="1300">
+                <a:latin typeface="Arial" panose="020B0604020202020204" pitchFamily="34" charset="0"/>
+              </a:rPr>
+              <a:t>səhifəsinə yükləyirik. </a:t>
+            </a:r>
+          </a:p>
+          <a:p>
+            <a:pPr>
+              <a:lnSpc>
+                <a:spcPct val="150000"/>
+              </a:lnSpc>
+              <a:buNone/>
+            </a:pPr>
+            <a:endParaRPr kumimoji="0" lang="az-Latn-AZ" altLang="en-US" sz="1300" b="0" i="0" u="none" strike="noStrike" cap="none" normalizeH="0" baseline="0">
+              <a:ln>
+                <a:noFill/>
+              </a:ln>
+              <a:solidFill>
+                <a:schemeClr val="tx1"/>
+              </a:solidFill>
+              <a:effectLst/>
+              <a:latin typeface="Arial" panose="020B0604020202020204" pitchFamily="34" charset="0"/>
+            </a:endParaRPr>
+          </a:p>
+          <a:p>
+            <a:pPr>
+              <a:lnSpc>
+                <a:spcPct val="150000"/>
+              </a:lnSpc>
+              <a:buNone/>
+            </a:pPr>
+            <a:r>
+              <a:rPr lang="az-Latn-AZ" altLang="en-US" sz="1300">
+                <a:latin typeface="Arial" panose="020B0604020202020204" pitchFamily="34" charset="0"/>
+              </a:rPr>
+              <a:t>Burada da, </a:t>
+            </a:r>
+            <a:r>
+              <a:rPr lang="en-US" altLang="en-US" sz="1300" b="1">
+                <a:latin typeface="Arial" panose="020B0604020202020204" pitchFamily="34" charset="0"/>
+              </a:rPr>
+              <a:t>@extends </a:t>
+            </a:r>
+            <a:r>
+              <a:rPr lang="az-Latn-AZ" altLang="en-US" sz="1300">
+                <a:latin typeface="Arial" panose="020B0604020202020204" pitchFamily="34" charset="0"/>
+              </a:rPr>
+              <a:t>və </a:t>
+            </a:r>
+            <a:r>
+              <a:rPr lang="en-US" altLang="en-US" sz="1300" b="1">
+                <a:latin typeface="Arial" panose="020B0604020202020204" pitchFamily="34" charset="0"/>
+              </a:rPr>
+              <a:t>@include </a:t>
+            </a:r>
+            <a:r>
+              <a:rPr lang="az-Latn-AZ" altLang="en-US" sz="1300">
+                <a:latin typeface="Arial" panose="020B0604020202020204" pitchFamily="34" charset="0"/>
+              </a:rPr>
+              <a:t>direktivlərində `</a:t>
+            </a:r>
+            <a:r>
+              <a:rPr lang="az-Latn-AZ" altLang="en-US" sz="1300" b="1">
+                <a:latin typeface="Arial" panose="020B0604020202020204" pitchFamily="34" charset="0"/>
+              </a:rPr>
+              <a:t>frontend</a:t>
+            </a:r>
+            <a:r>
+              <a:rPr lang="az-Latn-AZ" altLang="en-US" sz="1300">
+                <a:latin typeface="Arial" panose="020B0604020202020204" pitchFamily="34" charset="0"/>
+              </a:rPr>
+              <a:t>` yazısını, `</a:t>
+            </a:r>
+            <a:r>
+              <a:rPr lang="az-Latn-AZ" altLang="en-US" sz="1300" b="1">
+                <a:latin typeface="Arial" panose="020B0604020202020204" pitchFamily="34" charset="0"/>
+              </a:rPr>
+              <a:t>vendor</a:t>
+            </a:r>
+            <a:r>
+              <a:rPr lang="az-Latn-AZ" altLang="en-US" sz="1300">
+                <a:latin typeface="Arial" panose="020B0604020202020204" pitchFamily="34" charset="0"/>
+              </a:rPr>
+              <a:t>` yazısı ilə əvəz edirik.</a:t>
+            </a:r>
+            <a:endParaRPr kumimoji="0" lang="en-US" altLang="en-US" sz="1300" b="0" i="0" u="none" strike="noStrike" cap="none" normalizeH="0" baseline="0">
+              <a:ln>
+                <a:noFill/>
+              </a:ln>
+              <a:solidFill>
+                <a:schemeClr val="tx1"/>
+              </a:solidFill>
+              <a:effectLst/>
+              <a:latin typeface="Arial" panose="020B0604020202020204" pitchFamily="34" charset="0"/>
+            </a:endParaRPr>
+          </a:p>
+        </p:txBody>
+      </p:sp>
+      <p:pic>
+        <p:nvPicPr>
+          <p:cNvPr id="4" name="Picture 3">
+            <a:extLst>
+              <a:ext uri="{FF2B5EF4-FFF2-40B4-BE49-F238E27FC236}">
+                <a16:creationId xmlns:a16="http://schemas.microsoft.com/office/drawing/2014/main" id="{25F88DA2-3B85-785A-1997-8D580FB53652}"/>
+              </a:ext>
+            </a:extLst>
+          </p:cNvPr>
+          <p:cNvPicPr>
+            <a:picLocks noChangeAspect="1"/>
+          </p:cNvPicPr>
+          <p:nvPr/>
+        </p:nvPicPr>
+        <p:blipFill>
+          <a:blip r:embed="rId2"/>
+          <a:stretch>
+            <a:fillRect/>
+          </a:stretch>
+        </p:blipFill>
+        <p:spPr>
+          <a:xfrm>
+            <a:off x="6726487" y="0"/>
+            <a:ext cx="5465513" cy="6858000"/>
+          </a:xfrm>
+          <a:prstGeom prst="rect">
+            <a:avLst/>
+          </a:prstGeom>
+        </p:spPr>
+      </p:pic>
+    </p:spTree>
+    <p:extLst>
+      <p:ext uri="{BB962C8B-B14F-4D97-AF65-F5344CB8AC3E}">
+        <p14:creationId xmlns:p14="http://schemas.microsoft.com/office/powerpoint/2010/main" val="3095838342"/>
+      </p:ext>
+    </p:extLst>
+  </p:cSld>
+  <p:clrMapOvr>
+    <a:masterClrMapping/>
+  </p:clrMapOvr>
+</p:sld>
+</file>
+
+<file path=ppt/slides/slide4.xml><?xml version="1.0" encoding="utf-8"?>
+<p:sld xmlns:a="http://schemas.openxmlformats.org/drawingml/2006/main" xmlns:r="http://schemas.openxmlformats.org/officeDocument/2006/relationships" xmlns:p="http://schemas.openxmlformats.org/presentationml/2006/main">
+  <p:cSld>
+    <p:spTree>
+      <p:nvGrpSpPr>
+        <p:cNvPr id="1" name="">
+          <a:extLst>
+            <a:ext uri="{FF2B5EF4-FFF2-40B4-BE49-F238E27FC236}">
+              <a16:creationId xmlns:a16="http://schemas.microsoft.com/office/drawing/2014/main" id="{CD05BB29-EE28-27FA-BD68-6262512D1839}"/>
+            </a:ext>
+          </a:extLst>
+        </p:cNvPr>
+        <p:cNvGrpSpPr/>
+        <p:nvPr/>
+      </p:nvGrpSpPr>
+      <p:grpSpPr>
+        <a:xfrm>
+          <a:off x="0" y="0"/>
+          <a:ext cx="0" cy="0"/>
+          <a:chOff x="0" y="0"/>
+          <a:chExt cx="0" cy="0"/>
+        </a:xfrm>
+      </p:grpSpPr>
+      <p:sp>
+        <p:nvSpPr>
+          <p:cNvPr id="3" name="TextBox 2">
+            <a:extLst>
+              <a:ext uri="{FF2B5EF4-FFF2-40B4-BE49-F238E27FC236}">
+                <a16:creationId xmlns:a16="http://schemas.microsoft.com/office/drawing/2014/main" id="{2A86BADA-641B-65BA-2785-F96048CE83FC}"/>
+              </a:ext>
+            </a:extLst>
+          </p:cNvPr>
+          <p:cNvSpPr txBox="1"/>
+          <p:nvPr/>
+        </p:nvSpPr>
+        <p:spPr>
+          <a:xfrm>
+            <a:off x="217714" y="255046"/>
             <a:ext cx="11756571" cy="355354"/>
           </a:xfrm>
           <a:prstGeom prst="rect">
@@ -3541,25 +4351,890 @@
               <a:buNone/>
             </a:pPr>
             <a:r>
-              <a:rPr kumimoji="0" lang="en-US" altLang="en-US" sz="1300" b="0" i="0" u="none" strike="noStrike" cap="none" normalizeH="0" baseline="0">
-                <a:ln>
-                  <a:noFill/>
-                </a:ln>
-                <a:solidFill>
-                  <a:schemeClr val="tx1"/>
-                </a:solidFill>
-                <a:effectLst/>
-                <a:latin typeface="Arial" panose="020B0604020202020204" pitchFamily="34" charset="0"/>
-              </a:rPr>
-              <a:t>.</a:t>
-            </a:r>
-          </a:p>
-        </p:txBody>
-      </p:sp>
+              <a:rPr lang="en-US" altLang="en-US" sz="1300">
+                <a:latin typeface="Arial" panose="020B0604020202020204" pitchFamily="34" charset="0"/>
+              </a:rPr>
+              <a:t>Vendor </a:t>
+            </a:r>
+            <a:r>
+              <a:rPr lang="az-Latn-AZ" altLang="en-US" sz="1300">
+                <a:latin typeface="Arial" panose="020B0604020202020204" pitchFamily="34" charset="0"/>
+              </a:rPr>
+              <a:t>yarı Back olduğu üçün, onun kontrollerinidə </a:t>
+            </a:r>
+            <a:r>
+              <a:rPr lang="az-Latn-AZ" altLang="en-US" sz="1300" b="1">
+                <a:latin typeface="Arial" panose="020B0604020202020204" pitchFamily="34" charset="0"/>
+              </a:rPr>
+              <a:t>Backend</a:t>
+            </a:r>
+            <a:r>
+              <a:rPr lang="az-Latn-AZ" altLang="en-US" sz="1300">
+                <a:latin typeface="Arial" panose="020B0604020202020204" pitchFamily="34" charset="0"/>
+              </a:rPr>
+              <a:t> qovluğunda yaradırıq.</a:t>
+            </a:r>
+            <a:endParaRPr kumimoji="0" lang="en-US" altLang="en-US" sz="1300" b="0" i="0" u="none" strike="noStrike" cap="none" normalizeH="0" baseline="0">
+              <a:ln>
+                <a:noFill/>
+              </a:ln>
+              <a:solidFill>
+                <a:schemeClr val="tx1"/>
+              </a:solidFill>
+              <a:effectLst/>
+              <a:latin typeface="Arial" panose="020B0604020202020204" pitchFamily="34" charset="0"/>
+            </a:endParaRPr>
+          </a:p>
+        </p:txBody>
+      </p:sp>
+      <p:pic>
+        <p:nvPicPr>
+          <p:cNvPr id="4" name="Picture 3">
+            <a:extLst>
+              <a:ext uri="{FF2B5EF4-FFF2-40B4-BE49-F238E27FC236}">
+                <a16:creationId xmlns:a16="http://schemas.microsoft.com/office/drawing/2014/main" id="{556D93E2-9A25-FB0A-0D23-3961DE7BE98C}"/>
+              </a:ext>
+            </a:extLst>
+          </p:cNvPr>
+          <p:cNvPicPr>
+            <a:picLocks noChangeAspect="1"/>
+          </p:cNvPicPr>
+          <p:nvPr/>
+        </p:nvPicPr>
+        <p:blipFill>
+          <a:blip r:embed="rId2"/>
+          <a:stretch>
+            <a:fillRect/>
+          </a:stretch>
+        </p:blipFill>
+        <p:spPr>
+          <a:xfrm>
+            <a:off x="0" y="5086103"/>
+            <a:ext cx="9345329" cy="1771897"/>
+          </a:xfrm>
+          <a:prstGeom prst="rect">
+            <a:avLst/>
+          </a:prstGeom>
+        </p:spPr>
+      </p:pic>
     </p:spTree>
     <p:extLst>
       <p:ext uri="{BB962C8B-B14F-4D97-AF65-F5344CB8AC3E}">
-        <p14:creationId xmlns:p14="http://schemas.microsoft.com/office/powerpoint/2010/main" val="3095838342"/>
+        <p14:creationId xmlns:p14="http://schemas.microsoft.com/office/powerpoint/2010/main" val="2519734178"/>
+      </p:ext>
+    </p:extLst>
+  </p:cSld>
+  <p:clrMapOvr>
+    <a:masterClrMapping/>
+  </p:clrMapOvr>
+</p:sld>
+</file>
+
+<file path=ppt/slides/slide5.xml><?xml version="1.0" encoding="utf-8"?>
+<p:sld xmlns:a="http://schemas.openxmlformats.org/drawingml/2006/main" xmlns:r="http://schemas.openxmlformats.org/officeDocument/2006/relationships" xmlns:p="http://schemas.openxmlformats.org/presentationml/2006/main">
+  <p:cSld>
+    <p:spTree>
+      <p:nvGrpSpPr>
+        <p:cNvPr id="1" name="">
+          <a:extLst>
+            <a:ext uri="{FF2B5EF4-FFF2-40B4-BE49-F238E27FC236}">
+              <a16:creationId xmlns:a16="http://schemas.microsoft.com/office/drawing/2014/main" id="{CDE82AFD-F27C-A8C6-4E92-AA7EC8104A35}"/>
+            </a:ext>
+          </a:extLst>
+        </p:cNvPr>
+        <p:cNvGrpSpPr/>
+        <p:nvPr/>
+      </p:nvGrpSpPr>
+      <p:grpSpPr>
+        <a:xfrm>
+          <a:off x="0" y="0"/>
+          <a:ext cx="0" cy="0"/>
+          <a:chOff x="0" y="0"/>
+          <a:chExt cx="0" cy="0"/>
+        </a:xfrm>
+      </p:grpSpPr>
+      <p:sp>
+        <p:nvSpPr>
+          <p:cNvPr id="3" name="TextBox 2">
+            <a:extLst>
+              <a:ext uri="{FF2B5EF4-FFF2-40B4-BE49-F238E27FC236}">
+                <a16:creationId xmlns:a16="http://schemas.microsoft.com/office/drawing/2014/main" id="{7CAD4351-A1AA-258D-4882-77C97D5CF976}"/>
+              </a:ext>
+            </a:extLst>
+          </p:cNvPr>
+          <p:cNvSpPr txBox="1"/>
+          <p:nvPr/>
+        </p:nvSpPr>
+        <p:spPr>
+          <a:xfrm>
+            <a:off x="217714" y="255046"/>
+            <a:ext cx="11756571" cy="355354"/>
+          </a:xfrm>
+          <a:prstGeom prst="rect">
+            <a:avLst/>
+          </a:prstGeom>
+          <a:noFill/>
+        </p:spPr>
+        <p:txBody>
+          <a:bodyPr wrap="square">
+            <a:spAutoFit/>
+          </a:bodyPr>
+          <a:lstStyle/>
+          <a:p>
+            <a:pPr>
+              <a:lnSpc>
+                <a:spcPct val="150000"/>
+              </a:lnSpc>
+              <a:buNone/>
+            </a:pPr>
+            <a:r>
+              <a:rPr lang="az-Latn-AZ" altLang="en-US" sz="1300" b="1">
+                <a:latin typeface="Arial" panose="020B0604020202020204" pitchFamily="34" charset="0"/>
+              </a:rPr>
+              <a:t>Vendor</a:t>
+            </a:r>
+            <a:r>
+              <a:rPr lang="az-Latn-AZ" altLang="en-US" sz="1300">
+                <a:latin typeface="Arial" panose="020B0604020202020204" pitchFamily="34" charset="0"/>
+              </a:rPr>
+              <a:t> -un </a:t>
+            </a:r>
+            <a:r>
+              <a:rPr lang="az-Latn-AZ" altLang="en-US" sz="1300" b="1">
+                <a:latin typeface="Arial" panose="020B0604020202020204" pitchFamily="34" charset="0"/>
+              </a:rPr>
+              <a:t>profile</a:t>
+            </a:r>
+            <a:r>
+              <a:rPr lang="az-Latn-AZ" altLang="en-US" sz="1300">
+                <a:latin typeface="Arial" panose="020B0604020202020204" pitchFamily="34" charset="0"/>
+              </a:rPr>
+              <a:t> səhifəsinə keçmək üçün </a:t>
+            </a:r>
+            <a:r>
+              <a:rPr lang="az-Latn-AZ" altLang="en-US" sz="1300" b="1">
+                <a:latin typeface="Arial" panose="020B0604020202020204" pitchFamily="34" charset="0"/>
+              </a:rPr>
+              <a:t>ROUTE</a:t>
+            </a:r>
+            <a:r>
+              <a:rPr lang="az-Latn-AZ" altLang="en-US" sz="1300">
+                <a:latin typeface="Arial" panose="020B0604020202020204" pitchFamily="34" charset="0"/>
+              </a:rPr>
+              <a:t> yazırıq və </a:t>
+            </a:r>
+            <a:r>
+              <a:rPr lang="az-Latn-AZ" altLang="en-US" sz="1300" b="1">
+                <a:latin typeface="Arial" panose="020B0604020202020204" pitchFamily="34" charset="0"/>
+              </a:rPr>
+              <a:t>Controller</a:t>
+            </a:r>
+            <a:r>
+              <a:rPr lang="az-Latn-AZ" altLang="en-US" sz="1300">
+                <a:latin typeface="Arial" panose="020B0604020202020204" pitchFamily="34" charset="0"/>
+              </a:rPr>
+              <a:t> -i konfiqurasiya edirik. </a:t>
+            </a:r>
+            <a:endParaRPr kumimoji="0" lang="en-US" altLang="en-US" sz="1300" b="0" i="0" u="none" strike="noStrike" cap="none" normalizeH="0" baseline="0">
+              <a:ln>
+                <a:noFill/>
+              </a:ln>
+              <a:solidFill>
+                <a:schemeClr val="tx1"/>
+              </a:solidFill>
+              <a:effectLst/>
+              <a:latin typeface="Arial" panose="020B0604020202020204" pitchFamily="34" charset="0"/>
+            </a:endParaRPr>
+          </a:p>
+        </p:txBody>
+      </p:sp>
+      <p:pic>
+        <p:nvPicPr>
+          <p:cNvPr id="4" name="Picture 3">
+            <a:extLst>
+              <a:ext uri="{FF2B5EF4-FFF2-40B4-BE49-F238E27FC236}">
+                <a16:creationId xmlns:a16="http://schemas.microsoft.com/office/drawing/2014/main" id="{8BD53FB4-7700-1DC2-589C-3406DA9F35BE}"/>
+              </a:ext>
+            </a:extLst>
+          </p:cNvPr>
+          <p:cNvPicPr>
+            <a:picLocks noChangeAspect="1"/>
+          </p:cNvPicPr>
+          <p:nvPr/>
+        </p:nvPicPr>
+        <p:blipFill>
+          <a:blip r:embed="rId2"/>
+          <a:stretch>
+            <a:fillRect/>
+          </a:stretch>
+        </p:blipFill>
+        <p:spPr>
+          <a:xfrm>
+            <a:off x="0" y="3886895"/>
+            <a:ext cx="12192000" cy="2971105"/>
+          </a:xfrm>
+          <a:prstGeom prst="rect">
+            <a:avLst/>
+          </a:prstGeom>
+        </p:spPr>
+      </p:pic>
+    </p:spTree>
+    <p:extLst>
+      <p:ext uri="{BB962C8B-B14F-4D97-AF65-F5344CB8AC3E}">
+        <p14:creationId xmlns:p14="http://schemas.microsoft.com/office/powerpoint/2010/main" val="2009671068"/>
+      </p:ext>
+    </p:extLst>
+  </p:cSld>
+  <p:clrMapOvr>
+    <a:masterClrMapping/>
+  </p:clrMapOvr>
+</p:sld>
+</file>
+
+<file path=ppt/slides/slide6.xml><?xml version="1.0" encoding="utf-8"?>
+<p:sld xmlns:a="http://schemas.openxmlformats.org/drawingml/2006/main" xmlns:r="http://schemas.openxmlformats.org/officeDocument/2006/relationships" xmlns:p="http://schemas.openxmlformats.org/presentationml/2006/main">
+  <p:cSld>
+    <p:spTree>
+      <p:nvGrpSpPr>
+        <p:cNvPr id="1" name="">
+          <a:extLst>
+            <a:ext uri="{FF2B5EF4-FFF2-40B4-BE49-F238E27FC236}">
+              <a16:creationId xmlns:a16="http://schemas.microsoft.com/office/drawing/2014/main" id="{77F1714A-0A34-8255-1B01-67192AEB906E}"/>
+            </a:ext>
+          </a:extLst>
+        </p:cNvPr>
+        <p:cNvGrpSpPr/>
+        <p:nvPr/>
+      </p:nvGrpSpPr>
+      <p:grpSpPr>
+        <a:xfrm>
+          <a:off x="0" y="0"/>
+          <a:ext cx="0" cy="0"/>
+          <a:chOff x="0" y="0"/>
+          <a:chExt cx="0" cy="0"/>
+        </a:xfrm>
+      </p:grpSpPr>
+      <p:sp>
+        <p:nvSpPr>
+          <p:cNvPr id="3" name="TextBox 2">
+            <a:extLst>
+              <a:ext uri="{FF2B5EF4-FFF2-40B4-BE49-F238E27FC236}">
+                <a16:creationId xmlns:a16="http://schemas.microsoft.com/office/drawing/2014/main" id="{CB6529F8-EA16-D6E3-FA25-69165388EBD4}"/>
+              </a:ext>
+            </a:extLst>
+          </p:cNvPr>
+          <p:cNvSpPr txBox="1"/>
+          <p:nvPr/>
+        </p:nvSpPr>
+        <p:spPr>
+          <a:xfrm>
+            <a:off x="217714" y="255046"/>
+            <a:ext cx="11756571" cy="355354"/>
+          </a:xfrm>
+          <a:prstGeom prst="rect">
+            <a:avLst/>
+          </a:prstGeom>
+          <a:noFill/>
+        </p:spPr>
+        <p:txBody>
+          <a:bodyPr wrap="square">
+            <a:spAutoFit/>
+          </a:bodyPr>
+          <a:lstStyle/>
+          <a:p>
+            <a:pPr>
+              <a:lnSpc>
+                <a:spcPct val="150000"/>
+              </a:lnSpc>
+              <a:buNone/>
+            </a:pPr>
+            <a:r>
+              <a:rPr lang="az-Latn-AZ" altLang="en-US" sz="1300">
+                <a:latin typeface="Arial" panose="020B0604020202020204" pitchFamily="34" charset="0"/>
+              </a:rPr>
+              <a:t>Link vasitəsi ilə keçid edə bilməmiz üçün elementlərə </a:t>
+            </a:r>
+            <a:r>
+              <a:rPr lang="az-Latn-AZ" altLang="en-US" sz="1300" b="1">
+                <a:latin typeface="Arial" panose="020B0604020202020204" pitchFamily="34" charset="0"/>
+              </a:rPr>
+              <a:t>route</a:t>
+            </a:r>
+            <a:r>
+              <a:rPr lang="az-Latn-AZ" altLang="en-US" sz="1300">
+                <a:latin typeface="Arial" panose="020B0604020202020204" pitchFamily="34" charset="0"/>
+              </a:rPr>
+              <a:t> -larımı yazırıq :              </a:t>
+            </a:r>
+            <a:r>
+              <a:rPr lang="en-US" altLang="en-US" sz="1300">
+                <a:latin typeface="Arial" panose="020B0604020202020204" pitchFamily="34" charset="0"/>
+              </a:rPr>
+              <a:t>` </a:t>
+            </a:r>
+            <a:r>
+              <a:rPr lang="en-US" altLang="en-US" sz="1300" b="1">
+                <a:latin typeface="Arial" panose="020B0604020202020204" pitchFamily="34" charset="0"/>
+              </a:rPr>
+              <a:t>resources\views\vendor\dashboard\layouts\</a:t>
+            </a:r>
+            <a:r>
+              <a:rPr lang="en-US" altLang="en-US" sz="1300" b="1" u="sng">
+                <a:latin typeface="Arial" panose="020B0604020202020204" pitchFamily="34" charset="0"/>
+              </a:rPr>
+              <a:t>sidebar.blade.php </a:t>
+            </a:r>
+            <a:r>
+              <a:rPr lang="en-US" altLang="en-US" sz="1300">
+                <a:latin typeface="Arial" panose="020B0604020202020204" pitchFamily="34" charset="0"/>
+              </a:rPr>
+              <a:t>` </a:t>
+            </a:r>
+            <a:endParaRPr kumimoji="0" lang="en-US" altLang="en-US" sz="1300" b="0" i="0" u="none" strike="noStrike" cap="none" normalizeH="0" baseline="0">
+              <a:ln>
+                <a:noFill/>
+              </a:ln>
+              <a:solidFill>
+                <a:schemeClr val="tx1"/>
+              </a:solidFill>
+              <a:effectLst/>
+              <a:latin typeface="Arial" panose="020B0604020202020204" pitchFamily="34" charset="0"/>
+            </a:endParaRPr>
+          </a:p>
+        </p:txBody>
+      </p:sp>
+      <p:pic>
+        <p:nvPicPr>
+          <p:cNvPr id="4" name="Picture 3">
+            <a:extLst>
+              <a:ext uri="{FF2B5EF4-FFF2-40B4-BE49-F238E27FC236}">
+                <a16:creationId xmlns:a16="http://schemas.microsoft.com/office/drawing/2014/main" id="{BCA770C4-73DC-81C0-5751-B5F36975309D}"/>
+              </a:ext>
+            </a:extLst>
+          </p:cNvPr>
+          <p:cNvPicPr>
+            <a:picLocks noChangeAspect="1"/>
+          </p:cNvPicPr>
+          <p:nvPr/>
+        </p:nvPicPr>
+        <p:blipFill>
+          <a:blip r:embed="rId2"/>
+          <a:stretch>
+            <a:fillRect/>
+          </a:stretch>
+        </p:blipFill>
+        <p:spPr>
+          <a:xfrm>
+            <a:off x="3982123" y="1726162"/>
+            <a:ext cx="8209877" cy="5131837"/>
+          </a:xfrm>
+          <a:prstGeom prst="rect">
+            <a:avLst/>
+          </a:prstGeom>
+        </p:spPr>
+      </p:pic>
+    </p:spTree>
+    <p:extLst>
+      <p:ext uri="{BB962C8B-B14F-4D97-AF65-F5344CB8AC3E}">
+        <p14:creationId xmlns:p14="http://schemas.microsoft.com/office/powerpoint/2010/main" val="2855348932"/>
+      </p:ext>
+    </p:extLst>
+  </p:cSld>
+  <p:clrMapOvr>
+    <a:masterClrMapping/>
+  </p:clrMapOvr>
+</p:sld>
+</file>
+
+<file path=ppt/slides/slide7.xml><?xml version="1.0" encoding="utf-8"?>
+<p:sld xmlns:a="http://schemas.openxmlformats.org/drawingml/2006/main" xmlns:r="http://schemas.openxmlformats.org/officeDocument/2006/relationships" xmlns:p="http://schemas.openxmlformats.org/presentationml/2006/main">
+  <p:cSld>
+    <p:spTree>
+      <p:nvGrpSpPr>
+        <p:cNvPr id="1" name="">
+          <a:extLst>
+            <a:ext uri="{FF2B5EF4-FFF2-40B4-BE49-F238E27FC236}">
+              <a16:creationId xmlns:a16="http://schemas.microsoft.com/office/drawing/2014/main" id="{E7C2AE8E-D0EA-7E19-863E-E1538DB9055C}"/>
+            </a:ext>
+          </a:extLst>
+        </p:cNvPr>
+        <p:cNvGrpSpPr/>
+        <p:nvPr/>
+      </p:nvGrpSpPr>
+      <p:grpSpPr>
+        <a:xfrm>
+          <a:off x="0" y="0"/>
+          <a:ext cx="0" cy="0"/>
+          <a:chOff x="0" y="0"/>
+          <a:chExt cx="0" cy="0"/>
+        </a:xfrm>
+      </p:grpSpPr>
+      <p:sp>
+        <p:nvSpPr>
+          <p:cNvPr id="3" name="TextBox 2">
+            <a:extLst>
+              <a:ext uri="{FF2B5EF4-FFF2-40B4-BE49-F238E27FC236}">
+                <a16:creationId xmlns:a16="http://schemas.microsoft.com/office/drawing/2014/main" id="{11B68C66-F2B3-4ABA-8A24-294305E6BB59}"/>
+              </a:ext>
+            </a:extLst>
+          </p:cNvPr>
+          <p:cNvSpPr txBox="1"/>
+          <p:nvPr/>
+        </p:nvSpPr>
+        <p:spPr>
+          <a:xfrm>
+            <a:off x="217714" y="255046"/>
+            <a:ext cx="11756571" cy="655436"/>
+          </a:xfrm>
+          <a:prstGeom prst="rect">
+            <a:avLst/>
+          </a:prstGeom>
+          <a:noFill/>
+        </p:spPr>
+        <p:txBody>
+          <a:bodyPr wrap="square">
+            <a:spAutoFit/>
+          </a:bodyPr>
+          <a:lstStyle/>
+          <a:p>
+            <a:pPr>
+              <a:lnSpc>
+                <a:spcPct val="150000"/>
+              </a:lnSpc>
+              <a:buNone/>
+            </a:pPr>
+            <a:r>
+              <a:rPr lang="az-Latn-AZ" altLang="en-US" sz="1300" b="1">
+                <a:latin typeface="Arial" panose="020B0604020202020204" pitchFamily="34" charset="0"/>
+              </a:rPr>
+              <a:t>Vendor profile </a:t>
+            </a:r>
+            <a:r>
+              <a:rPr lang="az-Latn-AZ" altLang="en-US" sz="1300">
+                <a:latin typeface="Arial" panose="020B0604020202020204" pitchFamily="34" charset="0"/>
+              </a:rPr>
+              <a:t>səhifəsində </a:t>
+            </a:r>
+            <a:r>
+              <a:rPr lang="az-Latn-AZ" altLang="en-US" sz="1300" b="1">
+                <a:latin typeface="Arial" panose="020B0604020202020204" pitchFamily="34" charset="0"/>
+              </a:rPr>
+              <a:t>UPDATE</a:t>
+            </a:r>
+            <a:r>
+              <a:rPr lang="az-Latn-AZ" altLang="en-US" sz="1300">
+                <a:latin typeface="Arial" panose="020B0604020202020204" pitchFamily="34" charset="0"/>
+              </a:rPr>
+              <a:t> -lər edə bilməmiz üçün, </a:t>
+            </a:r>
+            <a:r>
+              <a:rPr lang="az-Latn-AZ" altLang="en-US" sz="1300" b="1">
+                <a:latin typeface="Arial" panose="020B0604020202020204" pitchFamily="34" charset="0"/>
+              </a:rPr>
+              <a:t>normal User </a:t>
+            </a:r>
+            <a:r>
+              <a:rPr lang="az-Latn-AZ" altLang="en-US" sz="1300">
+                <a:latin typeface="Arial" panose="020B0604020202020204" pitchFamily="34" charset="0"/>
+              </a:rPr>
+              <a:t>üçün istifadə etdiyimiz </a:t>
+            </a:r>
+            <a:r>
+              <a:rPr lang="az-Latn-AZ" altLang="en-US" sz="1300" b="1">
+                <a:latin typeface="Arial" panose="020B0604020202020204" pitchFamily="34" charset="0"/>
+              </a:rPr>
+              <a:t>route</a:t>
+            </a:r>
+            <a:r>
+              <a:rPr lang="az-Latn-AZ" altLang="en-US" sz="1300">
+                <a:latin typeface="Arial" panose="020B0604020202020204" pitchFamily="34" charset="0"/>
+              </a:rPr>
+              <a:t> -ları</a:t>
+            </a:r>
+            <a:r>
+              <a:rPr lang="en-US" altLang="en-US" sz="1300">
+                <a:latin typeface="Arial" panose="020B0604020202020204" pitchFamily="34" charset="0"/>
+              </a:rPr>
+              <a:t>, </a:t>
+            </a:r>
+            <a:r>
+              <a:rPr lang="az-Latn-AZ" altLang="en-US" sz="1300">
+                <a:latin typeface="Arial" panose="020B0604020202020204" pitchFamily="34" charset="0"/>
+              </a:rPr>
+              <a:t>`</a:t>
+            </a:r>
+            <a:r>
+              <a:rPr lang="en-US" altLang="en-US" sz="1300" b="1">
+                <a:latin typeface="Arial" panose="020B0604020202020204" pitchFamily="34" charset="0"/>
+              </a:rPr>
+              <a:t>web.php</a:t>
+            </a:r>
+            <a:r>
+              <a:rPr lang="az-Latn-AZ" altLang="en-US" sz="1300">
+                <a:latin typeface="Arial" panose="020B0604020202020204" pitchFamily="34" charset="0"/>
+              </a:rPr>
+              <a:t>`</a:t>
+            </a:r>
+            <a:r>
+              <a:rPr lang="en-US" altLang="en-US" sz="1300">
+                <a:latin typeface="Arial" panose="020B0604020202020204" pitchFamily="34" charset="0"/>
+              </a:rPr>
+              <a:t> </a:t>
+            </a:r>
+            <a:r>
+              <a:rPr lang="az-Latn-AZ" altLang="en-US" sz="1300">
+                <a:latin typeface="Arial" panose="020B0604020202020204" pitchFamily="34" charset="0"/>
+              </a:rPr>
+              <a:t>faylından `</a:t>
+            </a:r>
+            <a:r>
+              <a:rPr lang="az-Latn-AZ" altLang="en-US" sz="1300" b="1">
+                <a:latin typeface="Arial" panose="020B0604020202020204" pitchFamily="34" charset="0"/>
+              </a:rPr>
+              <a:t>routes\vendor.php</a:t>
+            </a:r>
+            <a:r>
+              <a:rPr lang="az-Latn-AZ" altLang="en-US" sz="1300">
+                <a:latin typeface="Arial" panose="020B0604020202020204" pitchFamily="34" charset="0"/>
+              </a:rPr>
+              <a:t>` faylına köçürürük. Çünki onsuzda bu hissələr bir birinə bənzəyir. Sadəcə biraz dəyişikliklər etmək lazımdır.</a:t>
+            </a:r>
+            <a:endParaRPr kumimoji="0" lang="en-US" altLang="en-US" sz="1300" b="0" i="0" u="none" strike="noStrike" cap="none" normalizeH="0" baseline="0">
+              <a:ln>
+                <a:noFill/>
+              </a:ln>
+              <a:solidFill>
+                <a:schemeClr val="tx1"/>
+              </a:solidFill>
+              <a:effectLst/>
+              <a:latin typeface="Arial" panose="020B0604020202020204" pitchFamily="34" charset="0"/>
+            </a:endParaRPr>
+          </a:p>
+        </p:txBody>
+      </p:sp>
+      <p:pic>
+        <p:nvPicPr>
+          <p:cNvPr id="4" name="Picture 3">
+            <a:extLst>
+              <a:ext uri="{FF2B5EF4-FFF2-40B4-BE49-F238E27FC236}">
+                <a16:creationId xmlns:a16="http://schemas.microsoft.com/office/drawing/2014/main" id="{0CFD7F7B-CBA8-D5B5-C8A9-504637B7D258}"/>
+              </a:ext>
+            </a:extLst>
+          </p:cNvPr>
+          <p:cNvPicPr>
+            <a:picLocks noChangeAspect="1"/>
+          </p:cNvPicPr>
+          <p:nvPr/>
+        </p:nvPicPr>
+        <p:blipFill>
+          <a:blip r:embed="rId2"/>
+          <a:stretch>
+            <a:fillRect/>
+          </a:stretch>
+        </p:blipFill>
+        <p:spPr>
+          <a:xfrm>
+            <a:off x="0" y="2923626"/>
+            <a:ext cx="11745964" cy="3934374"/>
+          </a:xfrm>
+          <a:prstGeom prst="rect">
+            <a:avLst/>
+          </a:prstGeom>
+        </p:spPr>
+      </p:pic>
+    </p:spTree>
+    <p:extLst>
+      <p:ext uri="{BB962C8B-B14F-4D97-AF65-F5344CB8AC3E}">
+        <p14:creationId xmlns:p14="http://schemas.microsoft.com/office/powerpoint/2010/main" val="3162640686"/>
+      </p:ext>
+    </p:extLst>
+  </p:cSld>
+  <p:clrMapOvr>
+    <a:masterClrMapping/>
+  </p:clrMapOvr>
+</p:sld>
+</file>
+
+<file path=ppt/slides/slide8.xml><?xml version="1.0" encoding="utf-8"?>
+<p:sld xmlns:a="http://schemas.openxmlformats.org/drawingml/2006/main" xmlns:r="http://schemas.openxmlformats.org/officeDocument/2006/relationships" xmlns:p="http://schemas.openxmlformats.org/presentationml/2006/main">
+  <p:cSld>
+    <p:spTree>
+      <p:nvGrpSpPr>
+        <p:cNvPr id="1" name="">
+          <a:extLst>
+            <a:ext uri="{FF2B5EF4-FFF2-40B4-BE49-F238E27FC236}">
+              <a16:creationId xmlns:a16="http://schemas.microsoft.com/office/drawing/2014/main" id="{C33F374D-7489-0C93-6B99-92668C3BC9C6}"/>
+            </a:ext>
+          </a:extLst>
+        </p:cNvPr>
+        <p:cNvGrpSpPr/>
+        <p:nvPr/>
+      </p:nvGrpSpPr>
+      <p:grpSpPr>
+        <a:xfrm>
+          <a:off x="0" y="0"/>
+          <a:ext cx="0" cy="0"/>
+          <a:chOff x="0" y="0"/>
+          <a:chExt cx="0" cy="0"/>
+        </a:xfrm>
+      </p:grpSpPr>
+      <p:sp>
+        <p:nvSpPr>
+          <p:cNvPr id="3" name="TextBox 2">
+            <a:extLst>
+              <a:ext uri="{FF2B5EF4-FFF2-40B4-BE49-F238E27FC236}">
+                <a16:creationId xmlns:a16="http://schemas.microsoft.com/office/drawing/2014/main" id="{5E17C60B-CBF6-CE46-CE39-A754292AFFDC}"/>
+              </a:ext>
+            </a:extLst>
+          </p:cNvPr>
+          <p:cNvSpPr txBox="1"/>
+          <p:nvPr/>
+        </p:nvSpPr>
+        <p:spPr>
+          <a:xfrm>
+            <a:off x="217714" y="255046"/>
+            <a:ext cx="11756571" cy="355354"/>
+          </a:xfrm>
+          <a:prstGeom prst="rect">
+            <a:avLst/>
+          </a:prstGeom>
+          <a:noFill/>
+        </p:spPr>
+        <p:txBody>
+          <a:bodyPr wrap="square">
+            <a:spAutoFit/>
+          </a:bodyPr>
+          <a:lstStyle/>
+          <a:p>
+            <a:pPr>
+              <a:lnSpc>
+                <a:spcPct val="150000"/>
+              </a:lnSpc>
+              <a:buNone/>
+            </a:pPr>
+            <a:r>
+              <a:rPr lang="en-US" altLang="en-US" sz="1300">
+                <a:latin typeface="Arial" panose="020B0604020202020204" pitchFamily="34" charset="0"/>
+              </a:rPr>
+              <a:t>app\Http\Controllers\Backend\VendorProfileController.php</a:t>
+            </a:r>
+            <a:endParaRPr kumimoji="0" lang="en-US" altLang="en-US" sz="1300" b="0" i="0" u="none" strike="noStrike" cap="none" normalizeH="0" baseline="0">
+              <a:ln>
+                <a:noFill/>
+              </a:ln>
+              <a:solidFill>
+                <a:schemeClr val="tx1"/>
+              </a:solidFill>
+              <a:effectLst/>
+              <a:latin typeface="Arial" panose="020B0604020202020204" pitchFamily="34" charset="0"/>
+            </a:endParaRPr>
+          </a:p>
+        </p:txBody>
+      </p:sp>
+      <p:grpSp>
+        <p:nvGrpSpPr>
+          <p:cNvPr id="9" name="Group 8">
+            <a:extLst>
+              <a:ext uri="{FF2B5EF4-FFF2-40B4-BE49-F238E27FC236}">
+                <a16:creationId xmlns:a16="http://schemas.microsoft.com/office/drawing/2014/main" id="{D09AEB8F-37B7-E4BD-5019-21426596F76F}"/>
+              </a:ext>
+            </a:extLst>
+          </p:cNvPr>
+          <p:cNvGrpSpPr/>
+          <p:nvPr/>
+        </p:nvGrpSpPr>
+        <p:grpSpPr>
+          <a:xfrm>
+            <a:off x="7907908" y="0"/>
+            <a:ext cx="4284092" cy="6671952"/>
+            <a:chOff x="2937802" y="0"/>
+            <a:chExt cx="4284092" cy="6671952"/>
+          </a:xfrm>
+        </p:grpSpPr>
+        <p:pic>
+          <p:nvPicPr>
+            <p:cNvPr id="4" name="Picture 3">
+              <a:extLst>
+                <a:ext uri="{FF2B5EF4-FFF2-40B4-BE49-F238E27FC236}">
+                  <a16:creationId xmlns:a16="http://schemas.microsoft.com/office/drawing/2014/main" id="{09F20025-5F97-9D62-80BA-7250E561DAD8}"/>
+                </a:ext>
+              </a:extLst>
+            </p:cNvPr>
+            <p:cNvPicPr>
+              <a:picLocks noChangeAspect="1"/>
+            </p:cNvPicPr>
+            <p:nvPr/>
+          </p:nvPicPr>
+          <p:blipFill>
+            <a:blip r:embed="rId2"/>
+            <a:stretch>
+              <a:fillRect/>
+            </a:stretch>
+          </p:blipFill>
+          <p:spPr>
+            <a:xfrm>
+              <a:off x="2937803" y="0"/>
+              <a:ext cx="4284091" cy="4651435"/>
+            </a:xfrm>
+            <a:prstGeom prst="rect">
+              <a:avLst/>
+            </a:prstGeom>
+          </p:spPr>
+        </p:pic>
+        <p:pic>
+          <p:nvPicPr>
+            <p:cNvPr id="8" name="Picture 7">
+              <a:extLst>
+                <a:ext uri="{FF2B5EF4-FFF2-40B4-BE49-F238E27FC236}">
+                  <a16:creationId xmlns:a16="http://schemas.microsoft.com/office/drawing/2014/main" id="{C3449986-7FB6-EEB4-19A9-D4F1951C7C87}"/>
+                </a:ext>
+              </a:extLst>
+            </p:cNvPr>
+            <p:cNvPicPr>
+              <a:picLocks noChangeAspect="1"/>
+            </p:cNvPicPr>
+            <p:nvPr/>
+          </p:nvPicPr>
+          <p:blipFill>
+            <a:blip r:embed="rId3"/>
+            <a:stretch>
+              <a:fillRect/>
+            </a:stretch>
+          </p:blipFill>
+          <p:spPr>
+            <a:xfrm>
+              <a:off x="2937802" y="4649682"/>
+              <a:ext cx="4284091" cy="2022270"/>
+            </a:xfrm>
+            <a:prstGeom prst="rect">
+              <a:avLst/>
+            </a:prstGeom>
+          </p:spPr>
+        </p:pic>
+      </p:grpSp>
+    </p:spTree>
+    <p:extLst>
+      <p:ext uri="{BB962C8B-B14F-4D97-AF65-F5344CB8AC3E}">
+        <p14:creationId xmlns:p14="http://schemas.microsoft.com/office/powerpoint/2010/main" val="1505125482"/>
+      </p:ext>
+    </p:extLst>
+  </p:cSld>
+  <p:clrMapOvr>
+    <a:masterClrMapping/>
+  </p:clrMapOvr>
+</p:sld>
+</file>
+
+<file path=ppt/slides/slide9.xml><?xml version="1.0" encoding="utf-8"?>
+<p:sld xmlns:a="http://schemas.openxmlformats.org/drawingml/2006/main" xmlns:r="http://schemas.openxmlformats.org/officeDocument/2006/relationships" xmlns:p="http://schemas.openxmlformats.org/presentationml/2006/main">
+  <p:cSld>
+    <p:spTree>
+      <p:nvGrpSpPr>
+        <p:cNvPr id="1" name="">
+          <a:extLst>
+            <a:ext uri="{FF2B5EF4-FFF2-40B4-BE49-F238E27FC236}">
+              <a16:creationId xmlns:a16="http://schemas.microsoft.com/office/drawing/2014/main" id="{0C1A5FDC-79D4-E80C-1EC8-D122CDABC8CD}"/>
+            </a:ext>
+          </a:extLst>
+        </p:cNvPr>
+        <p:cNvGrpSpPr/>
+        <p:nvPr/>
+      </p:nvGrpSpPr>
+      <p:grpSpPr>
+        <a:xfrm>
+          <a:off x="0" y="0"/>
+          <a:ext cx="0" cy="0"/>
+          <a:chOff x="0" y="0"/>
+          <a:chExt cx="0" cy="0"/>
+        </a:xfrm>
+      </p:grpSpPr>
+      <p:sp>
+        <p:nvSpPr>
+          <p:cNvPr id="3" name="TextBox 2">
+            <a:extLst>
+              <a:ext uri="{FF2B5EF4-FFF2-40B4-BE49-F238E27FC236}">
+                <a16:creationId xmlns:a16="http://schemas.microsoft.com/office/drawing/2014/main" id="{6038EDAA-B5A4-7443-C9C3-9C4ADEF615D8}"/>
+              </a:ext>
+            </a:extLst>
+          </p:cNvPr>
+          <p:cNvSpPr txBox="1"/>
+          <p:nvPr/>
+        </p:nvSpPr>
+        <p:spPr>
+          <a:xfrm>
+            <a:off x="217714" y="255046"/>
+            <a:ext cx="11756571" cy="355354"/>
+          </a:xfrm>
+          <a:prstGeom prst="rect">
+            <a:avLst/>
+          </a:prstGeom>
+          <a:noFill/>
+        </p:spPr>
+        <p:txBody>
+          <a:bodyPr wrap="square">
+            <a:spAutoFit/>
+          </a:bodyPr>
+          <a:lstStyle/>
+          <a:p>
+            <a:pPr>
+              <a:lnSpc>
+                <a:spcPct val="150000"/>
+              </a:lnSpc>
+              <a:buNone/>
+            </a:pPr>
+            <a:r>
+              <a:rPr lang="en-US" altLang="en-US" sz="1300">
+                <a:latin typeface="Arial" panose="020B0604020202020204" pitchFamily="34" charset="0"/>
+              </a:rPr>
+              <a:t>resources\views\vendor\dashboard\profile.blade.php</a:t>
+            </a:r>
+            <a:endParaRPr kumimoji="0" lang="en-US" altLang="en-US" sz="1300" b="0" i="0" u="none" strike="noStrike" cap="none" normalizeH="0" baseline="0">
+              <a:ln>
+                <a:noFill/>
+              </a:ln>
+              <a:solidFill>
+                <a:schemeClr val="tx1"/>
+              </a:solidFill>
+              <a:effectLst/>
+              <a:latin typeface="Arial" panose="020B0604020202020204" pitchFamily="34" charset="0"/>
+            </a:endParaRPr>
+          </a:p>
+        </p:txBody>
+      </p:sp>
+      <p:pic>
+        <p:nvPicPr>
+          <p:cNvPr id="4" name="Picture 3">
+            <a:extLst>
+              <a:ext uri="{FF2B5EF4-FFF2-40B4-BE49-F238E27FC236}">
+                <a16:creationId xmlns:a16="http://schemas.microsoft.com/office/drawing/2014/main" id="{E48C0268-B4B6-5B9E-1896-E2CC80F09E26}"/>
+              </a:ext>
+            </a:extLst>
+          </p:cNvPr>
+          <p:cNvPicPr>
+            <a:picLocks noChangeAspect="1"/>
+          </p:cNvPicPr>
+          <p:nvPr/>
+        </p:nvPicPr>
+        <p:blipFill>
+          <a:blip r:embed="rId2"/>
+          <a:stretch>
+            <a:fillRect/>
+          </a:stretch>
+        </p:blipFill>
+        <p:spPr>
+          <a:xfrm>
+            <a:off x="3997654" y="1026366"/>
+            <a:ext cx="8194346" cy="5831633"/>
+          </a:xfrm>
+          <a:prstGeom prst="rect">
+            <a:avLst/>
+          </a:prstGeom>
+        </p:spPr>
+      </p:pic>
+    </p:spTree>
+    <p:extLst>
+      <p:ext uri="{BB962C8B-B14F-4D97-AF65-F5344CB8AC3E}">
+        <p14:creationId xmlns:p14="http://schemas.microsoft.com/office/powerpoint/2010/main" val="3558523418"/>
       </p:ext>
     </p:extLst>
   </p:cSld>

</xml_diff>